<commit_message>
Add Tidy Data teaching deck; intro slide 1 hero-on-top
- slides/tidy-data/: 15-slide reveal.js deck for the Sep 8 session —
  concept anchors keyed to the run sheet (the one rule, one value per
  cell, formatting is not data, missing values, three states of a date,
  locale, QA vs QC, export to CSV, change log, downstream/AI, verify by
  counting, recap), inline diagrams, speaker notes with timings. Live at
  /slides/tidy-data/
- intro deck slide 1: hero image moved to the top, welcome text below it
  (reveal + the shareable PPTX)
- dropped em dashes from both decks per house style

Co-Authored-By: Claude Sonnet 5 <noreply@anthropic.com>
Claude-Session: https://claude.ai/code/session_01K3AfSmCsy5xZwtnXQua8QA
</commit_message>
<xml_diff>
--- a/files/UC Carpentries Fall 2026 - Intro (3 slides).pptx
+++ b/files/UC Carpentries Fall 2026 - Intro (3 slides).pptx
@@ -10671,8 +10671,8 @@
         </p:blipFill>
         <p:spPr>
           <a:xfrm>
-            <a:off x="1066800" y="2424364"/>
-            <a:ext cx="10058400" cy="4433637"/>
+            <a:off x="1706880" y="320040"/>
+            <a:ext cx="8778240" cy="3869356"/>
           </a:xfrm>
           <a:prstGeom prst="rect">
             <a:avLst/>
@@ -10687,8 +10687,8 @@
         </p:nvSpPr>
         <p:spPr>
           <a:xfrm>
-            <a:off x="548640" y="292608"/>
-            <a:ext cx="10058400" cy="365760"/>
+            <a:off x="914400" y="4445427"/>
+            <a:ext cx="10363200" cy="365760"/>
           </a:xfrm>
           <a:prstGeom prst="rect">
             <a:avLst/>
@@ -10701,7 +10701,7 @@
           </a:bodyPr>
           <a:lstStyle/>
           <a:p>
-            <a:pPr algn="l"/>
+            <a:pPr algn="ctr"/>
             <a:r>
               <a:rPr sz="1400" b="1" spc="160">
                 <a:solidFill>
@@ -10722,8 +10722,8 @@
         </p:nvSpPr>
         <p:spPr>
           <a:xfrm>
-            <a:off x="502920" y="603504"/>
-            <a:ext cx="10058400" cy="1005840"/>
+            <a:off x="914400" y="4774611"/>
+            <a:ext cx="10363200" cy="822960"/>
           </a:xfrm>
           <a:prstGeom prst="rect">
             <a:avLst/>
@@ -10736,9 +10736,9 @@
           </a:bodyPr>
           <a:lstStyle/>
           <a:p>
-            <a:pPr algn="l"/>
+            <a:pPr algn="ctr"/>
             <a:r>
-              <a:rPr sz="5400" b="1">
+              <a:rPr sz="4000" b="1">
                 <a:solidFill>
                   <a:srgbClr val="1D4E79"/>
                 </a:solidFill>
@@ -10757,8 +10757,8 @@
         </p:nvSpPr>
         <p:spPr>
           <a:xfrm>
-            <a:off x="548640" y="1673352"/>
-            <a:ext cx="10515600" cy="457200"/>
+            <a:off x="914400" y="5542707"/>
+            <a:ext cx="10363200" cy="411480"/>
           </a:xfrm>
           <a:prstGeom prst="rect">
             <a:avLst/>
@@ -10771,9 +10771,9 @@
           </a:bodyPr>
           <a:lstStyle/>
           <a:p>
-            <a:pPr algn="l"/>
+            <a:pPr algn="ctr"/>
             <a:r>
-              <a:rPr sz="1600" b="1">
+              <a:rPr sz="1500" b="1">
                 <a:solidFill>
                   <a:srgbClr val="1A202C"/>
                 </a:solidFill>
@@ -10792,8 +10792,8 @@
         </p:nvSpPr>
         <p:spPr>
           <a:xfrm>
-            <a:off x="548640" y="2130552"/>
-            <a:ext cx="7315200" cy="411480"/>
+            <a:off x="914400" y="5963331"/>
+            <a:ext cx="10363200" cy="365760"/>
           </a:xfrm>
           <a:prstGeom prst="rect">
             <a:avLst/>
@@ -10806,7 +10806,7 @@
           </a:bodyPr>
           <a:lstStyle/>
           <a:p>
-            <a:pPr algn="l"/>
+            <a:pPr algn="ctr"/>
             <a:r>
               <a:rPr sz="1400" b="1">
                 <a:solidFill>
@@ -10827,8 +10827,8 @@
         </p:nvSpPr>
         <p:spPr>
           <a:xfrm>
-            <a:off x="566928" y="2487168"/>
-            <a:ext cx="3703320" cy="40640"/>
+            <a:off x="4267200" y="6292515"/>
+            <a:ext cx="3657600" cy="38100"/>
           </a:xfrm>
           <a:prstGeom prst="rect">
             <a:avLst/>

</xml_diff>